<commit_message>
Fix bundled pricing to require 2+ packages; correct Dhanani Law pricing
"Bundled" pricing was being applied to single-package recommendations,
where there is nothing to bundle. Added an explicit bundling rule across
the pricing logic docs: the discounted bundled price only applies when
2+ packages are recommended together; a single package is priced at its
stand-alone rate with no savings/bundling callout.

Corrected the Dhanani Law Sales Companion and Proposal, which had priced
a standalone Elite Coach recommendation at its bundled rate ($2,600/mo)
after marketing was deferred to Phase 2 — now $3,497/mo stand-alone, with
an added objection response for the price change.

Co-Authored-By: Claude Sonnet 5 <noreply@anthropic.com>
Claude-Session: https://claude.ai/code/session_01QdSPvsnddLgYWAsVW42rUB
</commit_message>
<xml_diff>
--- a/dhanani-law/Dhanani_Law_August_6_2026_Proposal.pptx
+++ b/dhanani-law/Dhanani_Law_August_6_2026_Proposal.pptx
@@ -8800,7 +8800,7 @@
                 </a:solidFill>
                 <a:latin typeface="Calibri"/>
               </a:rPr>
-              <a:t>$2,600</a:t>
+              <a:t>$3,497</a:t>
             </a:r>
           </a:p>
         </p:txBody>
@@ -8846,84 +8846,6 @@
         </p:nvSpPr>
         <p:spPr>
           <a:xfrm>
-            <a:off x="2322576" y="1426464"/>
-            <a:ext cx="914400" cy="237744"/>
-          </a:xfrm>
-          <a:prstGeom prst="rect">
-            <a:avLst/>
-          </a:prstGeom>
-          <a:noFill/>
-        </p:spPr>
-        <p:txBody>
-          <a:bodyPr wrap="square"/>
-          <a:lstStyle/>
-          <a:p>
-            <a:pPr algn="l"/>
-            <a:r>
-              <a:rPr sz="1100" b="0" i="0">
-                <a:solidFill>
-                  <a:srgbClr val="334155"/>
-                </a:solidFill>
-                <a:latin typeface="Calibri"/>
-              </a:rPr>
-              <a:t>$3,497/mo</a:t>
-            </a:r>
-          </a:p>
-        </p:txBody>
-      </p:sp>
-      <p:sp>
-        <p:nvSpPr>
-          <p:cNvPr id="11" name="Rectangle 10"/>
-          <p:cNvSpPr/>
-          <p:nvPr/>
-        </p:nvSpPr>
-        <p:spPr>
-          <a:xfrm>
-            <a:off x="2322576" y="1527048"/>
-            <a:ext cx="804672" cy="9144"/>
-          </a:xfrm>
-          <a:prstGeom prst="rect">
-            <a:avLst/>
-          </a:prstGeom>
-          <a:solidFill>
-            <a:srgbClr val="334155"/>
-          </a:solidFill>
-          <a:ln>
-            <a:solidFill>
-              <a:srgbClr val="FFFFFF"/>
-            </a:solidFill>
-          </a:ln>
-        </p:spPr>
-        <p:style>
-          <a:lnRef idx="1">
-            <a:schemeClr val="accent1"/>
-          </a:lnRef>
-          <a:fillRef idx="3">
-            <a:schemeClr val="accent1"/>
-          </a:fillRef>
-          <a:effectRef idx="2">
-            <a:schemeClr val="accent1"/>
-          </a:effectRef>
-          <a:fontRef idx="minor">
-            <a:schemeClr val="lt1"/>
-          </a:fontRef>
-        </p:style>
-        <p:txBody>
-          <a:bodyPr rtlCol="0" anchor="ctr"/>
-          <a:lstStyle/>
-          <a:p>
-            <a:pPr algn="ctr"/>
-          </a:p>
-        </p:txBody>
-      </p:sp>
-      <p:sp>
-        <p:nvSpPr>
-          <p:cNvPr id="12" name="TextBox 11"/>
-          <p:cNvSpPr txBox="1"/>
-          <p:nvPr/>
-        </p:nvSpPr>
-        <p:spPr>
-          <a:xfrm>
             <a:off x="475488" y="1792224"/>
             <a:ext cx="3803904" cy="201168"/>
           </a:xfrm>
@@ -8951,7 +8873,7 @@
       </p:sp>
       <p:sp>
         <p:nvSpPr>
-          <p:cNvPr id="13" name="Rectangle 12"/>
+          <p:cNvPr id="11" name="Rectangle 10"/>
           <p:cNvSpPr/>
           <p:nvPr/>
         </p:nvSpPr>
@@ -8996,7 +8918,7 @@
       </p:sp>
       <p:sp>
         <p:nvSpPr>
-          <p:cNvPr id="14" name="TextBox 13"/>
+          <p:cNvPr id="12" name="TextBox 11"/>
           <p:cNvSpPr txBox="1"/>
           <p:nvPr/>
         </p:nvSpPr>
@@ -9022,14 +8944,14 @@
                 </a:solidFill>
                 <a:latin typeface="Calibri"/>
               </a:rPr>
-              <a:t>BUNDLE TOTAL</a:t>
-            </a:r>
-          </a:p>
-        </p:txBody>
-      </p:sp>
-      <p:sp>
-        <p:nvSpPr>
-          <p:cNvPr id="15" name="TextBox 14"/>
+              <a:t>TOTAL INVESTMENT</a:t>
+            </a:r>
+          </a:p>
+        </p:txBody>
+      </p:sp>
+      <p:sp>
+        <p:nvSpPr>
+          <p:cNvPr id="13" name="TextBox 12"/>
           <p:cNvSpPr txBox="1"/>
           <p:nvPr/>
         </p:nvSpPr>
@@ -9055,47 +8977,14 @@
                 </a:solidFill>
                 <a:latin typeface="Calibri"/>
               </a:rPr>
-              <a:t>$2,600 / mo</a:t>
-            </a:r>
-          </a:p>
-        </p:txBody>
-      </p:sp>
-      <p:sp>
-        <p:nvSpPr>
-          <p:cNvPr id="16" name="TextBox 15"/>
-          <p:cNvSpPr txBox="1"/>
-          <p:nvPr/>
-        </p:nvSpPr>
-        <p:spPr>
-          <a:xfrm>
-            <a:off x="2670048" y="3493008"/>
-            <a:ext cx="1737360" cy="347472"/>
-          </a:xfrm>
-          <a:prstGeom prst="rect">
-            <a:avLst/>
-          </a:prstGeom>
-          <a:noFill/>
-        </p:spPr>
-        <p:txBody>
-          <a:bodyPr wrap="square"/>
-          <a:lstStyle/>
-          <a:p>
-            <a:pPr algn="l"/>
-            <a:r>
-              <a:rPr sz="800" b="0" i="0">
-                <a:solidFill>
-                  <a:srgbClr val="7CA0C0"/>
-                </a:solidFill>
-                <a:latin typeface="Calibri"/>
-              </a:rPr>
-              <a:t>Save $897/mo by bundling</a:t>
-            </a:r>
-          </a:p>
-        </p:txBody>
-      </p:sp>
-      <p:sp>
-        <p:nvSpPr>
-          <p:cNvPr id="17" name="Rectangle 16"/>
+              <a:t>$3,497 / mo</a:t>
+            </a:r>
+          </a:p>
+        </p:txBody>
+      </p:sp>
+      <p:sp>
+        <p:nvSpPr>
+          <p:cNvPr id="14" name="Rectangle 13"/>
           <p:cNvSpPr/>
           <p:nvPr/>
         </p:nvSpPr>
@@ -9140,7 +9029,7 @@
       </p:sp>
       <p:sp>
         <p:nvSpPr>
-          <p:cNvPr id="18" name="TextBox 17"/>
+          <p:cNvPr id="15" name="TextBox 14"/>
           <p:cNvSpPr txBox="1"/>
           <p:nvPr/>
         </p:nvSpPr>
@@ -9173,7 +9062,7 @@
       </p:sp>
       <p:sp>
         <p:nvSpPr>
-          <p:cNvPr id="19" name="Rectangle 18"/>
+          <p:cNvPr id="16" name="Rectangle 15"/>
           <p:cNvSpPr/>
           <p:nvPr/>
         </p:nvSpPr>
@@ -9218,7 +9107,7 @@
       </p:sp>
       <p:sp>
         <p:nvSpPr>
-          <p:cNvPr id="20" name="TextBox 19"/>
+          <p:cNvPr id="17" name="TextBox 16"/>
           <p:cNvSpPr txBox="1"/>
           <p:nvPr/>
         </p:nvSpPr>
@@ -9251,7 +9140,7 @@
       </p:sp>
       <p:sp>
         <p:nvSpPr>
-          <p:cNvPr id="21" name="TextBox 20"/>
+          <p:cNvPr id="18" name="TextBox 17"/>
           <p:cNvSpPr txBox="1"/>
           <p:nvPr/>
         </p:nvSpPr>
@@ -9284,7 +9173,7 @@
       </p:sp>
       <p:sp>
         <p:nvSpPr>
-          <p:cNvPr id="22" name="TextBox 21"/>
+          <p:cNvPr id="19" name="TextBox 18"/>
           <p:cNvSpPr txBox="1"/>
           <p:nvPr/>
         </p:nvSpPr>
@@ -9317,7 +9206,7 @@
       </p:sp>
       <p:sp>
         <p:nvSpPr>
-          <p:cNvPr id="23" name="Rectangle 22"/>
+          <p:cNvPr id="20" name="Rectangle 19"/>
           <p:cNvSpPr/>
           <p:nvPr/>
         </p:nvSpPr>
@@ -9362,7 +9251,7 @@
       </p:sp>
       <p:sp>
         <p:nvSpPr>
-          <p:cNvPr id="24" name="TextBox 23"/>
+          <p:cNvPr id="21" name="TextBox 20"/>
           <p:cNvSpPr txBox="1"/>
           <p:nvPr/>
         </p:nvSpPr>
@@ -9395,7 +9284,7 @@
       </p:sp>
       <p:sp>
         <p:nvSpPr>
-          <p:cNvPr id="25" name="TextBox 24"/>
+          <p:cNvPr id="22" name="TextBox 21"/>
           <p:cNvSpPr txBox="1"/>
           <p:nvPr/>
         </p:nvSpPr>
@@ -9428,7 +9317,7 @@
       </p:sp>
       <p:sp>
         <p:nvSpPr>
-          <p:cNvPr id="26" name="TextBox 25"/>
+          <p:cNvPr id="23" name="TextBox 22"/>
           <p:cNvSpPr txBox="1"/>
           <p:nvPr/>
         </p:nvSpPr>
@@ -9461,7 +9350,7 @@
       </p:sp>
       <p:sp>
         <p:nvSpPr>
-          <p:cNvPr id="27" name="TextBox 26"/>
+          <p:cNvPr id="24" name="TextBox 23"/>
           <p:cNvSpPr txBox="1"/>
           <p:nvPr/>
         </p:nvSpPr>
@@ -9494,7 +9383,7 @@
       </p:sp>
       <p:sp>
         <p:nvSpPr>
-          <p:cNvPr id="28" name="TextBox 27"/>
+          <p:cNvPr id="25" name="TextBox 24"/>
           <p:cNvSpPr txBox="1"/>
           <p:nvPr/>
         </p:nvSpPr>
@@ -9527,7 +9416,7 @@
       </p:sp>
       <p:sp>
         <p:nvSpPr>
-          <p:cNvPr id="29" name="Rectangle 28"/>
+          <p:cNvPr id="26" name="Rectangle 25"/>
           <p:cNvSpPr/>
           <p:nvPr/>
         </p:nvSpPr>
@@ -9572,7 +9461,7 @@
       </p:sp>
       <p:sp>
         <p:nvSpPr>
-          <p:cNvPr id="30" name="TextBox 29"/>
+          <p:cNvPr id="27" name="TextBox 26"/>
           <p:cNvSpPr txBox="1"/>
           <p:nvPr/>
         </p:nvSpPr>
@@ -9605,7 +9494,7 @@
       </p:sp>
       <p:sp>
         <p:nvSpPr>
-          <p:cNvPr id="31" name="TextBox 30"/>
+          <p:cNvPr id="28" name="TextBox 27"/>
           <p:cNvSpPr txBox="1"/>
           <p:nvPr/>
         </p:nvSpPr>
@@ -9638,7 +9527,7 @@
       </p:sp>
       <p:sp>
         <p:nvSpPr>
-          <p:cNvPr id="32" name="Rectangle 31"/>
+          <p:cNvPr id="29" name="Rectangle 28"/>
           <p:cNvSpPr/>
           <p:nvPr/>
         </p:nvSpPr>
@@ -9683,7 +9572,7 @@
       </p:sp>
       <p:sp>
         <p:nvSpPr>
-          <p:cNvPr id="33" name="TextBox 32"/>
+          <p:cNvPr id="30" name="TextBox 29"/>
           <p:cNvSpPr txBox="1"/>
           <p:nvPr/>
         </p:nvSpPr>
@@ -9716,7 +9605,7 @@
       </p:sp>
       <p:sp>
         <p:nvSpPr>
-          <p:cNvPr id="34" name="TextBox 33"/>
+          <p:cNvPr id="31" name="TextBox 30"/>
           <p:cNvSpPr txBox="1"/>
           <p:nvPr/>
         </p:nvSpPr>
@@ -9749,7 +9638,7 @@
       </p:sp>
       <p:sp>
         <p:nvSpPr>
-          <p:cNvPr id="35" name="Rectangle 34"/>
+          <p:cNvPr id="32" name="Rectangle 31"/>
           <p:cNvSpPr/>
           <p:nvPr/>
         </p:nvSpPr>
@@ -9794,7 +9683,7 @@
       </p:sp>
       <p:sp>
         <p:nvSpPr>
-          <p:cNvPr id="36" name="TextBox 35"/>
+          <p:cNvPr id="33" name="TextBox 32"/>
           <p:cNvSpPr txBox="1"/>
           <p:nvPr/>
         </p:nvSpPr>
@@ -9827,7 +9716,7 @@
       </p:sp>
       <p:sp>
         <p:nvSpPr>
-          <p:cNvPr id="37" name="TextBox 36"/>
+          <p:cNvPr id="34" name="TextBox 33"/>
           <p:cNvSpPr txBox="1"/>
           <p:nvPr/>
         </p:nvSpPr>
@@ -9860,7 +9749,7 @@
       </p:sp>
       <p:sp>
         <p:nvSpPr>
-          <p:cNvPr id="38" name="Rectangle 37"/>
+          <p:cNvPr id="35" name="Rectangle 34"/>
           <p:cNvSpPr/>
           <p:nvPr/>
         </p:nvSpPr>
@@ -9905,7 +9794,7 @@
       </p:sp>
       <p:sp>
         <p:nvSpPr>
-          <p:cNvPr id="39" name="TextBox 38"/>
+          <p:cNvPr id="36" name="TextBox 35"/>
           <p:cNvSpPr txBox="1"/>
           <p:nvPr/>
         </p:nvSpPr>
@@ -9938,7 +9827,7 @@
       </p:sp>
       <p:sp>
         <p:nvSpPr>
-          <p:cNvPr id="40" name="TextBox 39"/>
+          <p:cNvPr id="37" name="TextBox 36"/>
           <p:cNvSpPr txBox="1"/>
           <p:nvPr/>
         </p:nvSpPr>
@@ -9971,7 +9860,7 @@
       </p:sp>
       <p:sp>
         <p:nvSpPr>
-          <p:cNvPr id="41" name="Rectangle 40"/>
+          <p:cNvPr id="38" name="Rectangle 37"/>
           <p:cNvSpPr/>
           <p:nvPr/>
         </p:nvSpPr>
@@ -10016,7 +9905,7 @@
       </p:sp>
       <p:sp>
         <p:nvSpPr>
-          <p:cNvPr id="42" name="TextBox 41"/>
+          <p:cNvPr id="39" name="TextBox 38"/>
           <p:cNvSpPr txBox="1"/>
           <p:nvPr/>
         </p:nvSpPr>
@@ -10049,7 +9938,7 @@
       </p:sp>
       <p:sp>
         <p:nvSpPr>
-          <p:cNvPr id="43" name="TextBox 42"/>
+          <p:cNvPr id="40" name="TextBox 39"/>
           <p:cNvSpPr txBox="1"/>
           <p:nvPr/>
         </p:nvSpPr>
@@ -10082,7 +9971,7 @@
       </p:sp>
       <p:sp>
         <p:nvSpPr>
-          <p:cNvPr id="44" name="Rectangle 43"/>
+          <p:cNvPr id="41" name="Rectangle 40"/>
           <p:cNvSpPr/>
           <p:nvPr/>
         </p:nvSpPr>
@@ -10127,7 +10016,7 @@
       </p:sp>
       <p:sp>
         <p:nvSpPr>
-          <p:cNvPr id="45" name="TextBox 44"/>
+          <p:cNvPr id="42" name="TextBox 41"/>
           <p:cNvSpPr txBox="1"/>
           <p:nvPr/>
         </p:nvSpPr>
@@ -10160,7 +10049,7 @@
       </p:sp>
       <p:sp>
         <p:nvSpPr>
-          <p:cNvPr id="46" name="Rectangle 45"/>
+          <p:cNvPr id="43" name="Rectangle 42"/>
           <p:cNvSpPr/>
           <p:nvPr/>
         </p:nvSpPr>
@@ -10205,7 +10094,7 @@
       </p:sp>
       <p:sp>
         <p:nvSpPr>
-          <p:cNvPr id="47" name="TextBox 46"/>
+          <p:cNvPr id="44" name="TextBox 43"/>
           <p:cNvSpPr txBox="1"/>
           <p:nvPr/>
         </p:nvSpPr>
@@ -10238,7 +10127,7 @@
       </p:sp>
       <p:sp>
         <p:nvSpPr>
-          <p:cNvPr id="48" name="TextBox 47"/>
+          <p:cNvPr id="45" name="TextBox 44"/>
           <p:cNvSpPr txBox="1"/>
           <p:nvPr/>
         </p:nvSpPr>

</xml_diff>